<commit_message>
docs: update all presentation decks to 12-slide GASH.Control specification
</commit_message>
<xml_diff>
--- a/Forte_Control_Pitch_Deck.pptx
+++ b/Forte_Control_Pitch_Deck.pptx
@@ -6390,7 +6390,7 @@
               </a:defRPr>
             </a:pPr>
             <a:r>
-              <a:t>https://cams-preserve-beneficial-rights.trycloudflare.com</a:t>
+              <a:t>http://localhost:8000</a:t>
             </a:r>
           </a:p>
           <a:p>
@@ -6406,23 +6406,7 @@
               </a:defRPr>
             </a:pPr>
             <a:r>
-              <a:t>Публичный защищенный HTTPS-доступ через Cloudflare Tunnel.</a:t>
-            </a:r>
-          </a:p>
-          <a:p>
-            <a:pPr>
-              <a:spcBef>
-                <a:spcPts val="400"/>
-              </a:spcBef>
-              <a:defRPr sz="1100">
-                <a:solidFill>
-                  <a:srgbClr val="A8A6B3"/>
-                </a:solidFill>
-                <a:latin typeface="Arial"/>
-              </a:defRPr>
-            </a:pPr>
-            <a:r>
-              <a:t>Локальный адрес: http://localhost:8000</a:t>
+              <a:t>Публичный туннель для жюри подключается одной командой без перезапуска сервера.</a:t>
             </a:r>
           </a:p>
         </p:txBody>
@@ -6546,6 +6530,22 @@
             <a:br/>
             <a:r>
               <a:t>X-API-Key: forte-datathon-2026-key</a:t>
+            </a:r>
+          </a:p>
+          <a:p>
+            <a:pPr>
+              <a:spcBef>
+                <a:spcPts val="400"/>
+              </a:spcBef>
+              <a:defRPr sz="1100">
+                <a:solidFill>
+                  <a:srgbClr val="A8A6B3"/>
+                </a:solidFill>
+                <a:latin typeface="Arial"/>
+              </a:defRPr>
+            </a:pPr>
+            <a:r>
+              <a:t>Документация Swagger UI: /docs</a:t>
             </a:r>
           </a:p>
         </p:txBody>

</xml_diff>